<commit_message>
Add a Two-Package Grids results slide
build-slides.py gains slide 11, "Results on Two-Package Grids": mean P(true
goal) and time per method (max-term, SharpSAT-TD, MC-SAT) and d4 compiles per
grid size, 3x3-7x7, from CLARA/TwoPackage/results (last attempt of each run).
The archive slide now lists the two-package instances in place of the
"current work" bullet.  CLARA-slides.pptx regenerated; CLARA-preview.pdf
re-rendered with LibreOffice.

Co-Authored-By: Claude Opus 5.5 <noreply@anthropic.com>
</commit_message>
<xml_diff>
--- a/CLARA-slides.pptx
+++ b/CLARA-slides.pptx
@@ -16,6 +16,7 @@
     <p:sldId id="264" r:id="rId15"/>
     <p:sldId id="265" r:id="rId16"/>
     <p:sldId id="266" r:id="rId17"/>
+    <p:sldId id="267" r:id="rId18"/>
   </p:sldIdLst>
   <p:sldSz cx="12191695" cy="6858000" type="screen4x3"/>
   <p:notesSz cx="6858000" cy="9144000"/>
@@ -4145,7 +4146,7 @@
           <a:lstStyle/>
           <a:p>
             <a:r>
-              <a:t>Test Problem Archive</a:t>
+              <a:t>Results on Two-Package Grids</a:t>
             </a:r>
           </a:p>
         </p:txBody>
@@ -4160,6 +4161,706 @@
             <p:ph idx="1"/>
           </p:nvPr>
         </p:nvSpPr>
+        <p:spPr/>
+        <p:txBody>
+          <a:bodyPr/>
+          <a:lstStyle/>
+          <a:p/>
+        </p:txBody>
+      </p:sp>
+      <p:sp>
+        <p:nvSpPr>
+          <p:cNvPr id="905" name="Body 5"/>
+          <p:cNvSpPr>
+            <a:spLocks noGrp="1"/>
+          </p:cNvSpPr>
+          <p:nvPr>
+            <p:ph idx="1"/>
+          </p:nvPr>
+        </p:nvSpPr>
+        <p:spPr>
+          <a:xfrm>
+            <a:off x="731520" y="5074920"/>
+            <a:ext cx="10698480" cy="1691640"/>
+          </a:xfrm>
+        </p:spPr>
+        <p:txBody>
+          <a:bodyPr wrap="square"/>
+          <a:lstStyle/>
+          <a:p>
+            <a:pPr>
+              <a:spcBef>
+                <a:spcPts val="600"/>
+              </a:spcBef>
+            </a:pPr>
+            <a:r>
+              <a:rPr sz="1700"/>
+              <a:t>P = mean probability given to the true goal over finished runs; time = mean per run; 20-minute limit; a method that timed out was not run on larger grids</a:t>
+            </a:r>
+          </a:p>
+          <a:p>
+            <a:pPr>
+              <a:spcBef>
+                <a:spcPts val="600"/>
+              </a:spcBef>
+            </a:pPr>
+            <a:r>
+              <a:rPr sz="1700"/>
+              <a:t>Counting stops early: SharpSAT-TD finished none of 8 runs on 6×6; † MC-SAT finished 4 of 16 on 5×5</a:t>
+            </a:r>
+          </a:p>
+          <a:p>
+            <a:pPr>
+              <a:spcBef>
+                <a:spcPts val="600"/>
+              </a:spcBef>
+            </a:pPr>
+            <a:r>
+              <a:rPr sz="1700"/>
+              <a:t>Max-term finishes everything, within 0.06 of exact counting, but its top goal is a tie in 216 of 240 runs</a:t>
+            </a:r>
+          </a:p>
+          <a:p>
+            <a:pPr>
+              <a:spcBef>
+                <a:spcPts val="600"/>
+              </a:spcBef>
+            </a:pPr>
+            <a:r>
+              <a:rPr sz="1700"/>
+              <a:t>d4 compiles through 6×6; each query then takes ≤ 0.26 s and matches SharpSAT-TD to 2·10⁻¹⁵</a:t>
+            </a:r>
+          </a:p>
+        </p:txBody>
+      </p:sp>
+      <p:sp>
+        <p:nvSpPr>
+          <p:cNvPr id="4" name="TextBox 3"/>
+          <p:cNvSpPr txBox="1"/>
+          <p:nvPr/>
+        </p:nvSpPr>
+        <p:spPr>
+          <a:xfrm>
+            <a:off x="731520" y="1280160"/>
+            <a:ext cx="10698480" cy="822960"/>
+          </a:xfrm>
+          <a:prstGeom prst="rect">
+            <a:avLst/>
+          </a:prstGeom>
+          <a:noFill/>
+        </p:spPr>
+        <p:txBody>
+          <a:bodyPr wrap="square">
+            <a:spAutoFit/>
+          </a:bodyPr>
+          <a:lstStyle/>
+          <a:p>
+            <a:r>
+              <a:rPr sz="2000"/>
+              <a:t>One truck, two packages, two possible destinations each; the agent delivers one package: 4 goals (chance = 0.25), 4 instances per grid, 1 … N−2 observed actions</a:t>
+            </a:r>
+          </a:p>
+        </p:txBody>
+      </p:sp>
+      <p:graphicFrame>
+        <p:nvGraphicFramePr>
+          <p:cNvPr id="5" name="Table 4"/>
+          <p:cNvGraphicFramePr>
+            <a:graphicFrameLocks noGrp="1"/>
+          </p:cNvGraphicFramePr>
+          <p:nvPr/>
+        </p:nvGraphicFramePr>
+        <p:xfrm>
+          <a:off x="731520" y="2057400"/>
+          <a:ext cx="10698480" cy="2560320"/>
+        </p:xfrm>
+        <a:graphic>
+          <a:graphicData uri="http://schemas.openxmlformats.org/drawingml/2006/table">
+            <a:tbl>
+              <a:tblPr firstRow="1" bandRow="1">
+                <a:tableStyleId>{5C22544A-7EE6-4342-B048-85BDC9FD1C3A}</a:tableStyleId>
+              </a:tblPr>
+              <a:tblGrid>
+                <a:gridCol w="1005840"/>
+                <a:gridCol w="1371600"/>
+                <a:gridCol w="2057400"/>
+                <a:gridCol w="2057400"/>
+                <a:gridCol w="2103120"/>
+                <a:gridCol w="2103120"/>
+              </a:tblGrid>
+              <a:tr h="426720">
+                <a:tc>
+                  <a:txBody>
+                    <a:bodyPr wrap="square"/>
+                    <a:lstStyle/>
+                    <a:p>
+                      <a:pPr algn="l"/>
+                      <a:r>
+                        <a:rPr sz="1600"/>
+                        <a:t>Grid</a:t>
+                      </a:r>
+                    </a:p>
+                  </a:txBody>
+                  <a:tcPr anchor="ctr"/>
+                </a:tc>
+                <a:tc>
+                  <a:txBody>
+                    <a:bodyPr wrap="square"/>
+                    <a:lstStyle/>
+                    <a:p>
+                      <a:pPr algn="ctr"/>
+                      <a:r>
+                        <a:rPr sz="1600"/>
+                        <a:t>CNF vars</a:t>
+                      </a:r>
+                    </a:p>
+                  </a:txBody>
+                  <a:tcPr anchor="ctr"/>
+                </a:tc>
+                <a:tc>
+                  <a:txBody>
+                    <a:bodyPr wrap="square"/>
+                    <a:lstStyle/>
+                    <a:p>
+                      <a:pPr algn="ctr"/>
+                      <a:r>
+                        <a:rPr sz="1600"/>
+                        <a:t>Max-term
+P / time</a:t>
+                      </a:r>
+                    </a:p>
+                  </a:txBody>
+                  <a:tcPr anchor="ctr"/>
+                </a:tc>
+                <a:tc>
+                  <a:txBody>
+                    <a:bodyPr wrap="square"/>
+                    <a:lstStyle/>
+                    <a:p>
+                      <a:pPr algn="ctr"/>
+                      <a:r>
+                        <a:rPr sz="1600"/>
+                        <a:t>SharpSAT-TD
+P / time</a:t>
+                      </a:r>
+                    </a:p>
+                  </a:txBody>
+                  <a:tcPr anchor="ctr"/>
+                </a:tc>
+                <a:tc>
+                  <a:txBody>
+                    <a:bodyPr wrap="square"/>
+                    <a:lstStyle/>
+                    <a:p>
+                      <a:pPr algn="ctr"/>
+                      <a:r>
+                        <a:rPr sz="1600"/>
+                        <a:t>MC-SAT
+P / time</a:t>
+                      </a:r>
+                    </a:p>
+                  </a:txBody>
+                  <a:tcPr anchor="ctr"/>
+                </a:tc>
+                <a:tc>
+                  <a:txBody>
+                    <a:bodyPr wrap="square"/>
+                    <a:lstStyle/>
+                    <a:p>
+                      <a:pPr algn="ctr"/>
+                      <a:r>
+                        <a:rPr sz="1600"/>
+                        <a:t>d4 compile
+done · time</a:t>
+                      </a:r>
+                    </a:p>
+                  </a:txBody>
+                  <a:tcPr anchor="ctr"/>
+                </a:tc>
+              </a:tr>
+              <a:tr h="426720">
+                <a:tc>
+                  <a:txBody>
+                    <a:bodyPr wrap="square"/>
+                    <a:lstStyle/>
+                    <a:p>
+                      <a:pPr algn="l"/>
+                      <a:r>
+                        <a:rPr sz="1600"/>
+                        <a:t>3×3</a:t>
+                      </a:r>
+                    </a:p>
+                  </a:txBody>
+                  <a:tcPr anchor="ctr"/>
+                </a:tc>
+                <a:tc>
+                  <a:txBody>
+                    <a:bodyPr wrap="square"/>
+                    <a:lstStyle/>
+                    <a:p>
+                      <a:pPr algn="ctr"/>
+                      <a:r>
+                        <a:rPr sz="1600"/>
+                        <a:t>752</a:t>
+                      </a:r>
+                    </a:p>
+                  </a:txBody>
+                  <a:tcPr anchor="ctr"/>
+                </a:tc>
+                <a:tc>
+                  <a:txBody>
+                    <a:bodyPr wrap="square"/>
+                    <a:lstStyle/>
+                    <a:p>
+                      <a:pPr algn="ctr"/>
+                      <a:r>
+                        <a:rPr sz="1600"/>
+                        <a:t>0.40 / 24 s</a:t>
+                      </a:r>
+                    </a:p>
+                  </a:txBody>
+                  <a:tcPr anchor="ctr"/>
+                </a:tc>
+                <a:tc>
+                  <a:txBody>
+                    <a:bodyPr wrap="square"/>
+                    <a:lstStyle/>
+                    <a:p>
+                      <a:pPr algn="ctr"/>
+                      <a:r>
+                        <a:rPr sz="1600"/>
+                        <a:t>0.46 / 28 s</a:t>
+                      </a:r>
+                    </a:p>
+                  </a:txBody>
+                  <a:tcPr anchor="ctr"/>
+                </a:tc>
+                <a:tc>
+                  <a:txBody>
+                    <a:bodyPr wrap="square"/>
+                    <a:lstStyle/>
+                    <a:p>
+                      <a:pPr algn="ctr"/>
+                      <a:r>
+                        <a:rPr sz="1600"/>
+                        <a:t>0.37 / 85 s</a:t>
+                      </a:r>
+                    </a:p>
+                  </a:txBody>
+                  <a:tcPr anchor="ctr"/>
+                </a:tc>
+                <a:tc>
+                  <a:txBody>
+                    <a:bodyPr wrap="square"/>
+                    <a:lstStyle/>
+                    <a:p>
+                      <a:pPr algn="ctr"/>
+                      <a:r>
+                        <a:rPr sz="1600"/>
+                        <a:t>4 of 4 · 4 s</a:t>
+                      </a:r>
+                    </a:p>
+                  </a:txBody>
+                  <a:tcPr anchor="ctr"/>
+                </a:tc>
+              </a:tr>
+              <a:tr h="426720">
+                <a:tc>
+                  <a:txBody>
+                    <a:bodyPr wrap="square"/>
+                    <a:lstStyle/>
+                    <a:p>
+                      <a:pPr algn="l"/>
+                      <a:r>
+                        <a:rPr sz="1600"/>
+                        <a:t>4×4</a:t>
+                      </a:r>
+                    </a:p>
+                  </a:txBody>
+                  <a:tcPr anchor="ctr"/>
+                </a:tc>
+                <a:tc>
+                  <a:txBody>
+                    <a:bodyPr wrap="square"/>
+                    <a:lstStyle/>
+                    <a:p>
+                      <a:pPr algn="ctr"/>
+                      <a:r>
+                        <a:rPr sz="1600"/>
+                        <a:t>1,893</a:t>
+                      </a:r>
+                    </a:p>
+                  </a:txBody>
+                  <a:tcPr anchor="ctr"/>
+                </a:tc>
+                <a:tc>
+                  <a:txBody>
+                    <a:bodyPr wrap="square"/>
+                    <a:lstStyle/>
+                    <a:p>
+                      <a:pPr algn="ctr"/>
+                      <a:r>
+                        <a:rPr sz="1600"/>
+                        <a:t>0.35 / 35 s</a:t>
+                      </a:r>
+                    </a:p>
+                  </a:txBody>
+                  <a:tcPr anchor="ctr"/>
+                </a:tc>
+                <a:tc>
+                  <a:txBody>
+                    <a:bodyPr wrap="square"/>
+                    <a:lstStyle/>
+                    <a:p>
+                      <a:pPr algn="ctr"/>
+                      <a:r>
+                        <a:rPr sz="1600"/>
+                        <a:t>0.39 / 52 s</a:t>
+                      </a:r>
+                    </a:p>
+                  </a:txBody>
+                  <a:tcPr anchor="ctr"/>
+                </a:tc>
+                <a:tc>
+                  <a:txBody>
+                    <a:bodyPr wrap="square"/>
+                    <a:lstStyle/>
+                    <a:p>
+                      <a:pPr algn="ctr"/>
+                      <a:r>
+                        <a:rPr sz="1600"/>
+                        <a:t>0.31 / 454 s</a:t>
+                      </a:r>
+                    </a:p>
+                  </a:txBody>
+                  <a:tcPr anchor="ctr"/>
+                </a:tc>
+                <a:tc>
+                  <a:txBody>
+                    <a:bodyPr wrap="square"/>
+                    <a:lstStyle/>
+                    <a:p>
+                      <a:pPr algn="ctr"/>
+                      <a:r>
+                        <a:rPr sz="1600"/>
+                        <a:t>4 of 4 · 5 s</a:t>
+                      </a:r>
+                    </a:p>
+                  </a:txBody>
+                  <a:tcPr anchor="ctr"/>
+                </a:tc>
+              </a:tr>
+              <a:tr h="426720">
+                <a:tc>
+                  <a:txBody>
+                    <a:bodyPr wrap="square"/>
+                    <a:lstStyle/>
+                    <a:p>
+                      <a:pPr algn="l"/>
+                      <a:r>
+                        <a:rPr sz="1600"/>
+                        <a:t>5×5</a:t>
+                      </a:r>
+                    </a:p>
+                  </a:txBody>
+                  <a:tcPr anchor="ctr"/>
+                </a:tc>
+                <a:tc>
+                  <a:txBody>
+                    <a:bodyPr wrap="square"/>
+                    <a:lstStyle/>
+                    <a:p>
+                      <a:pPr algn="ctr"/>
+                      <a:r>
+                        <a:rPr sz="1600"/>
+                        <a:t>3,147</a:t>
+                      </a:r>
+                    </a:p>
+                  </a:txBody>
+                  <a:tcPr anchor="ctr"/>
+                </a:tc>
+                <a:tc>
+                  <a:txBody>
+                    <a:bodyPr wrap="square"/>
+                    <a:lstStyle/>
+                    <a:p>
+                      <a:pPr algn="ctr"/>
+                      <a:r>
+                        <a:rPr sz="1600"/>
+                        <a:t>0.39 / 56 s</a:t>
+                      </a:r>
+                    </a:p>
+                  </a:txBody>
+                  <a:tcPr anchor="ctr"/>
+                </a:tc>
+                <a:tc>
+                  <a:txBody>
+                    <a:bodyPr wrap="square"/>
+                    <a:lstStyle/>
+                    <a:p>
+                      <a:pPr algn="ctr"/>
+                      <a:r>
+                        <a:rPr sz="1600"/>
+                        <a:t>0.41 / 67 s</a:t>
+                      </a:r>
+                    </a:p>
+                  </a:txBody>
+                  <a:tcPr anchor="ctr"/>
+                </a:tc>
+                <a:tc>
+                  <a:txBody>
+                    <a:bodyPr wrap="square"/>
+                    <a:lstStyle/>
+                    <a:p>
+                      <a:pPr algn="ctr"/>
+                      <a:r>
+                        <a:rPr sz="1600"/>
+                        <a:t>0.32 / 579 s †</a:t>
+                      </a:r>
+                    </a:p>
+                  </a:txBody>
+                  <a:tcPr anchor="ctr"/>
+                </a:tc>
+                <a:tc>
+                  <a:txBody>
+                    <a:bodyPr wrap="square"/>
+                    <a:lstStyle/>
+                    <a:p>
+                      <a:pPr algn="ctr"/>
+                      <a:r>
+                        <a:rPr sz="1600"/>
+                        <a:t>4 of 4 · 9 s</a:t>
+                      </a:r>
+                    </a:p>
+                  </a:txBody>
+                  <a:tcPr anchor="ctr"/>
+                </a:tc>
+              </a:tr>
+              <a:tr h="426720">
+                <a:tc>
+                  <a:txBody>
+                    <a:bodyPr wrap="square"/>
+                    <a:lstStyle/>
+                    <a:p>
+                      <a:pPr algn="l"/>
+                      <a:r>
+                        <a:rPr sz="1600"/>
+                        <a:t>6×6</a:t>
+                      </a:r>
+                    </a:p>
+                  </a:txBody>
+                  <a:tcPr anchor="ctr"/>
+                </a:tc>
+                <a:tc>
+                  <a:txBody>
+                    <a:bodyPr wrap="square"/>
+                    <a:lstStyle/>
+                    <a:p>
+                      <a:pPr algn="ctr"/>
+                      <a:r>
+                        <a:rPr sz="1600"/>
+                        <a:t>5,797</a:t>
+                      </a:r>
+                    </a:p>
+                  </a:txBody>
+                  <a:tcPr anchor="ctr"/>
+                </a:tc>
+                <a:tc>
+                  <a:txBody>
+                    <a:bodyPr wrap="square"/>
+                    <a:lstStyle/>
+                    <a:p>
+                      <a:pPr algn="ctr"/>
+                      <a:r>
+                        <a:rPr sz="1600"/>
+                        <a:t>0.39 / 103 s</a:t>
+                      </a:r>
+                    </a:p>
+                  </a:txBody>
+                  <a:tcPr anchor="ctr"/>
+                </a:tc>
+                <a:tc>
+                  <a:txBody>
+                    <a:bodyPr wrap="square"/>
+                    <a:lstStyle/>
+                    <a:p>
+                      <a:pPr algn="ctr"/>
+                      <a:r>
+                        <a:rPr sz="1600"/>
+                        <a:t>none finished</a:t>
+                      </a:r>
+                    </a:p>
+                  </a:txBody>
+                  <a:tcPr anchor="ctr"/>
+                </a:tc>
+                <a:tc>
+                  <a:txBody>
+                    <a:bodyPr wrap="square"/>
+                    <a:lstStyle/>
+                    <a:p>
+                      <a:pPr algn="ctr"/>
+                      <a:r>
+                        <a:rPr sz="1600"/>
+                        <a:t>not run</a:t>
+                      </a:r>
+                    </a:p>
+                  </a:txBody>
+                  <a:tcPr anchor="ctr"/>
+                </a:tc>
+                <a:tc>
+                  <a:txBody>
+                    <a:bodyPr wrap="square"/>
+                    <a:lstStyle/>
+                    <a:p>
+                      <a:pPr algn="ctr"/>
+                      <a:r>
+                        <a:rPr sz="1600"/>
+                        <a:t>4 of 4 · 105 s</a:t>
+                      </a:r>
+                    </a:p>
+                  </a:txBody>
+                  <a:tcPr anchor="ctr"/>
+                </a:tc>
+              </a:tr>
+              <a:tr h="426720">
+                <a:tc>
+                  <a:txBody>
+                    <a:bodyPr wrap="square"/>
+                    <a:lstStyle/>
+                    <a:p>
+                      <a:pPr algn="l"/>
+                      <a:r>
+                        <a:rPr sz="1600"/>
+                        <a:t>7×7</a:t>
+                      </a:r>
+                    </a:p>
+                  </a:txBody>
+                  <a:tcPr anchor="ctr"/>
+                </a:tc>
+                <a:tc>
+                  <a:txBody>
+                    <a:bodyPr wrap="square"/>
+                    <a:lstStyle/>
+                    <a:p>
+                      <a:pPr algn="ctr"/>
+                      <a:r>
+                        <a:rPr sz="1600"/>
+                        <a:t>9,925</a:t>
+                      </a:r>
+                    </a:p>
+                  </a:txBody>
+                  <a:tcPr anchor="ctr"/>
+                </a:tc>
+                <a:tc>
+                  <a:txBody>
+                    <a:bodyPr wrap="square"/>
+                    <a:lstStyle/>
+                    <a:p>
+                      <a:pPr algn="ctr"/>
+                      <a:r>
+                        <a:rPr sz="1600"/>
+                        <a:t>0.39 / 355 s</a:t>
+                      </a:r>
+                    </a:p>
+                  </a:txBody>
+                  <a:tcPr anchor="ctr"/>
+                </a:tc>
+                <a:tc>
+                  <a:txBody>
+                    <a:bodyPr wrap="square"/>
+                    <a:lstStyle/>
+                    <a:p>
+                      <a:pPr algn="ctr"/>
+                      <a:r>
+                        <a:rPr sz="1600"/>
+                        <a:t>not run</a:t>
+                      </a:r>
+                    </a:p>
+                  </a:txBody>
+                  <a:tcPr anchor="ctr"/>
+                </a:tc>
+                <a:tc>
+                  <a:txBody>
+                    <a:bodyPr wrap="square"/>
+                    <a:lstStyle/>
+                    <a:p>
+                      <a:pPr algn="ctr"/>
+                      <a:r>
+                        <a:rPr sz="1600"/>
+                        <a:t>not run</a:t>
+                      </a:r>
+                    </a:p>
+                  </a:txBody>
+                  <a:tcPr anchor="ctr"/>
+                </a:tc>
+                <a:tc>
+                  <a:txBody>
+                    <a:bodyPr wrap="square"/>
+                    <a:lstStyle/>
+                    <a:p>
+                      <a:pPr algn="ctr"/>
+                      <a:r>
+                        <a:rPr sz="1600"/>
+                        <a:t>2 of 4 · 207 s</a:t>
+                      </a:r>
+                    </a:p>
+                  </a:txBody>
+                  <a:tcPr anchor="ctr"/>
+                </a:tc>
+              </a:tr>
+            </a:tbl>
+          </a:graphicData>
+        </a:graphic>
+      </p:graphicFrame>
+    </p:spTree>
+  </p:cSld>
+  <p:clrMapOvr>
+    <a:masterClrMapping/>
+  </p:clrMapOvr>
+</p:sld>
+</file>
+
+<file path=ppt/slides/slide12.xml><?xml version="1.0" encoding="utf-8"?>
+<p:sld xmlns:a="http://schemas.openxmlformats.org/drawingml/2006/main" xmlns:p="http://schemas.openxmlformats.org/presentationml/2006/main" xmlns:r="http://schemas.openxmlformats.org/officeDocument/2006/relationships">
+  <p:cSld>
+    <p:spTree>
+      <p:nvGrpSpPr>
+        <p:cNvPr id="1" name=""/>
+        <p:cNvGrpSpPr/>
+        <p:nvPr/>
+      </p:nvGrpSpPr>
+      <p:grpSpPr/>
+      <p:sp>
+        <p:nvSpPr>
+          <p:cNvPr id="2" name="Title 1"/>
+          <p:cNvSpPr>
+            <a:spLocks noGrp="1"/>
+          </p:cNvSpPr>
+          <p:nvPr>
+            <p:ph type="title"/>
+          </p:nvPr>
+        </p:nvSpPr>
+        <p:spPr/>
+        <p:txBody>
+          <a:bodyPr/>
+          <a:lstStyle/>
+          <a:p>
+            <a:r>
+              <a:t>Test Problem Archive</a:t>
+            </a:r>
+          </a:p>
+        </p:txBody>
+      </p:sp>
+      <p:sp>
+        <p:nvSpPr>
+          <p:cNvPr id="3" name="Content Placeholder 2"/>
+          <p:cNvSpPr>
+            <a:spLocks noGrp="1"/>
+          </p:cNvSpPr>
+          <p:nvPr>
+            <p:ph idx="1"/>
+          </p:nvPr>
+        </p:nvSpPr>
         <p:spPr>
           <a:xfrm>
             <a:off x="731520" y="1463040"/>
@@ -4233,11 +4934,11 @@
             </a:pPr>
             <a:r>
               <a:rPr b="1" sz="2800"/>
-              <a:t>Baseline results:</a:t>
+              <a:t>Two-package instances:</a:t>
             </a:r>
             <a:r>
               <a:rPr sz="2800"/>
-              <a:t> the tables on the previous two slides</a:t>
+              <a:t> N×N grids, N = 3 … 7, two packages with two possible destinations each</a:t>
             </a:r>
           </a:p>
           <a:p>
@@ -4248,11 +4949,11 @@
             </a:pPr>
             <a:r>
               <a:rPr b="1" sz="2800"/>
-              <a:t>Current work:</a:t>
+              <a:t>Baseline results:</a:t>
             </a:r>
             <a:r>
               <a:rPr sz="2800"/>
-              <a:t> harder problems with multiple packages and destinations</a:t>
+              <a:t> the tables on the previous three slides</a:t>
             </a:r>
           </a:p>
         </p:txBody>

</xml_diff>

<commit_message>
Slides: CNF clauses beside CNF variables
The Simple Grids, Knowledge Compilation and Two-Package results tables gain a
CNF clauses column: mean clauses of the evidence-free recognition theory, from
SimpleGrid/results/compile-d4-summary.md and TwoPackage/results/compile-d4.jsonl
(all four problems of each size).  Also fixes the 3x3 two-package variable
mean, 752 -> 751 (671 + 3 x 778 over 4 = 751.25).

Co-Authored-By: Claude Opus 5.5 <noreply@anthropic.com>
</commit_message>
<xml_diff>
--- a/CLARA-slides.pptx
+++ b/CLARA-slides.pptx
@@ -3470,12 +3470,13 @@
                 <a:tableStyleId>{5C22544A-7EE6-4342-B048-85BDC9FD1C3A}</a:tableStyleId>
               </a:tblPr>
               <a:tblGrid>
+                <a:gridCol w="1005840"/>
                 <a:gridCol w="1188720"/>
-                <a:gridCol w="1371600"/>
-                <a:gridCol w="1645920"/>
-                <a:gridCol w="2103120"/>
-                <a:gridCol w="2194560"/>
-                <a:gridCol w="2194560"/>
+                <a:gridCol w="1280160"/>
+                <a:gridCol w="1463040"/>
+                <a:gridCol w="1737360"/>
+                <a:gridCol w="2011680"/>
+                <a:gridCol w="2011680"/>
               </a:tblGrid>
               <a:tr h="431074">
                 <a:tc>
@@ -3528,6 +3529,20 @@
                       <a:pPr algn="ctr"/>
                       <a:r>
                         <a:rPr sz="1600"/>
+                        <a:t>CNF clauses</a:t>
+                      </a:r>
+                    </a:p>
+                  </a:txBody>
+                  <a:tcPr anchor="ctr"/>
+                </a:tc>
+                <a:tc>
+                  <a:txBody>
+                    <a:bodyPr wrap="square"/>
+                    <a:lstStyle/>
+                    <a:p>
+                      <a:pPr algn="ctr"/>
+                      <a:r>
+                        <a:rPr sz="1600"/>
                         <a:t>Compile time</a:t>
                       </a:r>
                     </a:p>
@@ -3614,6 +3629,20 @@
                       <a:pPr algn="ctr"/>
                       <a:r>
                         <a:rPr sz="1600"/>
+                        <a:t>818</a:t>
+                      </a:r>
+                    </a:p>
+                  </a:txBody>
+                  <a:tcPr anchor="ctr"/>
+                </a:tc>
+                <a:tc>
+                  <a:txBody>
+                    <a:bodyPr wrap="square"/>
+                    <a:lstStyle/>
+                    <a:p>
+                      <a:pPr algn="ctr"/>
+                      <a:r>
+                        <a:rPr sz="1600"/>
                         <a:t>0.04 s</a:t>
                       </a:r>
                     </a:p>
@@ -3700,6 +3729,20 @@
                       <a:pPr algn="ctr"/>
                       <a:r>
                         <a:rPr sz="1600"/>
+                        <a:t>5,621</a:t>
+                      </a:r>
+                    </a:p>
+                  </a:txBody>
+                  <a:tcPr anchor="ctr"/>
+                </a:tc>
+                <a:tc>
+                  <a:txBody>
+                    <a:bodyPr wrap="square"/>
+                    <a:lstStyle/>
+                    <a:p>
+                      <a:pPr algn="ctr"/>
+                      <a:r>
+                        <a:rPr sz="1600"/>
                         <a:t>0.09 s</a:t>
                       </a:r>
                     </a:p>
@@ -3786,6 +3829,20 @@
                       <a:pPr algn="ctr"/>
                       <a:r>
                         <a:rPr sz="1600"/>
+                        <a:t>11,191</a:t>
+                      </a:r>
+                    </a:p>
+                  </a:txBody>
+                  <a:tcPr anchor="ctr"/>
+                </a:tc>
+                <a:tc>
+                  <a:txBody>
+                    <a:bodyPr wrap="square"/>
+                    <a:lstStyle/>
+                    <a:p>
+                      <a:pPr algn="ctr"/>
+                      <a:r>
+                        <a:rPr sz="1600"/>
                         <a:t>1.4 s</a:t>
                       </a:r>
                     </a:p>
@@ -3872,6 +3929,20 @@
                       <a:pPr algn="ctr"/>
                       <a:r>
                         <a:rPr sz="1600"/>
+                        <a:t>17,936</a:t>
+                      </a:r>
+                    </a:p>
+                  </a:txBody>
+                  <a:tcPr anchor="ctr"/>
+                </a:tc>
+                <a:tc>
+                  <a:txBody>
+                    <a:bodyPr wrap="square"/>
+                    <a:lstStyle/>
+                    <a:p>
+                      <a:pPr algn="ctr"/>
+                      <a:r>
+                        <a:rPr sz="1600"/>
                         <a:t>6.8 s</a:t>
                       </a:r>
                     </a:p>
@@ -3958,6 +4029,20 @@
                       <a:pPr algn="ctr"/>
                       <a:r>
                         <a:rPr sz="1600"/>
+                        <a:t>30,205</a:t>
+                      </a:r>
+                    </a:p>
+                  </a:txBody>
+                  <a:tcPr anchor="ctr"/>
+                </a:tc>
+                <a:tc>
+                  <a:txBody>
+                    <a:bodyPr wrap="square"/>
+                    <a:lstStyle/>
+                    <a:p>
+                      <a:pPr algn="ctr"/>
+                      <a:r>
+                        <a:rPr sz="1600"/>
                         <a:t>104 s</a:t>
                       </a:r>
                     </a:p>
@@ -4031,6 +4116,20 @@
                       <a:r>
                         <a:rPr sz="1600"/>
                         <a:t>5,616</a:t>
+                      </a:r>
+                    </a:p>
+                  </a:txBody>
+                  <a:tcPr anchor="ctr"/>
+                </a:tc>
+                <a:tc>
+                  <a:txBody>
+                    <a:bodyPr wrap="square"/>
+                    <a:lstStyle/>
+                    <a:p>
+                      <a:pPr algn="ctr"/>
+                      <a:r>
+                        <a:rPr sz="1600"/>
+                        <a:t>42,712</a:t>
                       </a:r>
                     </a:p>
                   </a:txBody>
@@ -4195,7 +4294,7 @@
             </a:pPr>
             <a:r>
               <a:rPr sz="1700"/>
-              <a:t>P = mean probability given to the true goal over finished runs; time = mean per run; 20-minute limit; a method that timed out was not run on larger grids</a:t>
+              <a:t>P = mean probability given to the true goal over finished runs; time = mean per run; CNF sizes are means over the 4 problems; 20-minute limit; a method that timed out was not run on larger grids</a:t>
             </a:r>
           </a:p>
           <a:p>
@@ -4281,12 +4380,13 @@
                 <a:tableStyleId>{5C22544A-7EE6-4342-B048-85BDC9FD1C3A}</a:tableStyleId>
               </a:tblPr>
               <a:tblGrid>
-                <a:gridCol w="1005840"/>
-                <a:gridCol w="1371600"/>
-                <a:gridCol w="2057400"/>
-                <a:gridCol w="2057400"/>
-                <a:gridCol w="2103120"/>
-                <a:gridCol w="2103120"/>
+                <a:gridCol w="868680"/>
+                <a:gridCol w="1097280"/>
+                <a:gridCol w="1325880"/>
+                <a:gridCol w="1828800"/>
+                <a:gridCol w="1828800"/>
+                <a:gridCol w="1828800"/>
+                <a:gridCol w="1920240"/>
               </a:tblGrid>
               <a:tr h="426720">
                 <a:tc>
@@ -4325,6 +4425,20 @@
                       <a:pPr algn="ctr"/>
                       <a:r>
                         <a:rPr sz="1600"/>
+                        <a:t>CNF clauses</a:t>
+                      </a:r>
+                    </a:p>
+                  </a:txBody>
+                  <a:tcPr anchor="ctr"/>
+                </a:tc>
+                <a:tc>
+                  <a:txBody>
+                    <a:bodyPr wrap="square"/>
+                    <a:lstStyle/>
+                    <a:p>
+                      <a:pPr algn="ctr"/>
+                      <a:r>
+                        <a:rPr sz="1600"/>
                         <a:t>Max-term
 P / time</a:t>
                       </a:r>
@@ -4401,7 +4515,21 @@
                       <a:pPr algn="ctr"/>
                       <a:r>
                         <a:rPr sz="1600"/>
-                        <a:t>752</a:t>
+                        <a:t>751</a:t>
+                      </a:r>
+                    </a:p>
+                  </a:txBody>
+                  <a:tcPr anchor="ctr"/>
+                </a:tc>
+                <a:tc>
+                  <a:txBody>
+                    <a:bodyPr wrap="square"/>
+                    <a:lstStyle/>
+                    <a:p>
+                      <a:pPr algn="ctr"/>
+                      <a:r>
+                        <a:rPr sz="1600"/>
+                        <a:t>10,533</a:t>
                       </a:r>
                     </a:p>
                   </a:txBody>
@@ -4501,6 +4629,20 @@
                       <a:pPr algn="ctr"/>
                       <a:r>
                         <a:rPr sz="1600"/>
+                        <a:t>40,065</a:t>
+                      </a:r>
+                    </a:p>
+                  </a:txBody>
+                  <a:tcPr anchor="ctr"/>
+                </a:tc>
+                <a:tc>
+                  <a:txBody>
+                    <a:bodyPr wrap="square"/>
+                    <a:lstStyle/>
+                    <a:p>
+                      <a:pPr algn="ctr"/>
+                      <a:r>
+                        <a:rPr sz="1600"/>
                         <a:t>0.35 / 35 s</a:t>
                       </a:r>
                     </a:p>
@@ -4587,6 +4729,20 @@
                       <a:pPr algn="ctr"/>
                       <a:r>
                         <a:rPr sz="1600"/>
+                        <a:t>93,878</a:t>
+                      </a:r>
+                    </a:p>
+                  </a:txBody>
+                  <a:tcPr anchor="ctr"/>
+                </a:tc>
+                <a:tc>
+                  <a:txBody>
+                    <a:bodyPr wrap="square"/>
+                    <a:lstStyle/>
+                    <a:p>
+                      <a:pPr algn="ctr"/>
+                      <a:r>
+                        <a:rPr sz="1600"/>
                         <a:t>0.39 / 56 s</a:t>
                       </a:r>
                     </a:p>
@@ -4673,6 +4829,20 @@
                       <a:pPr algn="ctr"/>
                       <a:r>
                         <a:rPr sz="1600"/>
+                        <a:t>234,150</a:t>
+                      </a:r>
+                    </a:p>
+                  </a:txBody>
+                  <a:tcPr anchor="ctr"/>
+                </a:tc>
+                <a:tc>
+                  <a:txBody>
+                    <a:bodyPr wrap="square"/>
+                    <a:lstStyle/>
+                    <a:p>
+                      <a:pPr algn="ctr"/>
+                      <a:r>
+                        <a:rPr sz="1600"/>
                         <a:t>0.39 / 103 s</a:t>
                       </a:r>
                     </a:p>
@@ -4746,6 +4916,20 @@
                       <a:r>
                         <a:rPr sz="1600"/>
                         <a:t>9,925</a:t>
+                      </a:r>
+                    </a:p>
+                  </a:txBody>
+                  <a:tcPr anchor="ctr"/>
+                </a:tc>
+                <a:tc>
+                  <a:txBody>
+                    <a:bodyPr wrap="square"/>
+                    <a:lstStyle/>
+                    <a:p>
+                      <a:pPr algn="ctr"/>
+                      <a:r>
+                        <a:rPr sz="1600"/>
+                        <a:t>523,734</a:t>
                       </a:r>
                     </a:p>
                   </a:txBody>
@@ -8074,7 +8258,7 @@
         </p:nvGraphicFramePr>
         <p:xfrm>
           <a:off x="731520" y="1371600"/>
-          <a:ext cx="10607040" cy="3291840"/>
+          <a:ext cx="10698480" cy="3291840"/>
         </p:xfrm>
         <a:graphic>
           <a:graphicData uri="http://schemas.openxmlformats.org/drawingml/2006/table">
@@ -8083,12 +8267,13 @@
                 <a:tableStyleId>{5C22544A-7EE6-4342-B048-85BDC9FD1C3A}</a:tableStyleId>
               </a:tblPr>
               <a:tblGrid>
-                <a:gridCol w="1188720"/>
-                <a:gridCol w="1097280"/>
-                <a:gridCol w="1463040"/>
-                <a:gridCol w="2286000"/>
-                <a:gridCol w="2286000"/>
-                <a:gridCol w="2286000"/>
+                <a:gridCol w="914400"/>
+                <a:gridCol w="868680"/>
+                <a:gridCol w="1143000"/>
+                <a:gridCol w="1371600"/>
+                <a:gridCol w="2103120"/>
+                <a:gridCol w="2148840"/>
+                <a:gridCol w="2148840"/>
               </a:tblGrid>
               <a:tr h="470262">
                 <a:tc>
@@ -8141,6 +8326,20 @@
                       <a:pPr algn="ctr"/>
                       <a:r>
                         <a:rPr sz="1600"/>
+                        <a:t>CNF clauses</a:t>
+                      </a:r>
+                    </a:p>
+                  </a:txBody>
+                  <a:tcPr anchor="ctr"/>
+                </a:tc>
+                <a:tc>
+                  <a:txBody>
+                    <a:bodyPr wrap="square"/>
+                    <a:lstStyle/>
+                    <a:p>
+                      <a:pPr algn="ctr"/>
+                      <a:r>
+                        <a:rPr sz="1600"/>
                         <a:t>Max-term
 P / time</a:t>
                       </a:r>
@@ -8230,6 +8429,20 @@
                       <a:pPr algn="ctr"/>
                       <a:r>
                         <a:rPr sz="1600"/>
+                        <a:t>818</a:t>
+                      </a:r>
+                    </a:p>
+                  </a:txBody>
+                  <a:tcPr anchor="ctr"/>
+                </a:tc>
+                <a:tc>
+                  <a:txBody>
+                    <a:bodyPr wrap="square"/>
+                    <a:lstStyle/>
+                    <a:p>
+                      <a:pPr algn="ctr"/>
+                      <a:r>
+                        <a:rPr sz="1600"/>
                         <a:t>0.50 / 12 s</a:t>
                       </a:r>
                     </a:p>
@@ -8316,6 +8529,20 @@
                       <a:pPr algn="ctr"/>
                       <a:r>
                         <a:rPr sz="1600"/>
+                        <a:t>2,609</a:t>
+                      </a:r>
+                    </a:p>
+                  </a:txBody>
+                  <a:tcPr anchor="ctr"/>
+                </a:tc>
+                <a:tc>
+                  <a:txBody>
+                    <a:bodyPr wrap="square"/>
+                    <a:lstStyle/>
+                    <a:p>
+                      <a:pPr algn="ctr"/>
+                      <a:r>
+                        <a:rPr sz="1600"/>
                         <a:t>0.33 / 16 s</a:t>
                       </a:r>
                     </a:p>
@@ -8402,6 +8629,20 @@
                       <a:pPr algn="ctr"/>
                       <a:r>
                         <a:rPr sz="1600"/>
+                        <a:t>5,621</a:t>
+                      </a:r>
+                    </a:p>
+                  </a:txBody>
+                  <a:tcPr anchor="ctr"/>
+                </a:tc>
+                <a:tc>
+                  <a:txBody>
+                    <a:bodyPr wrap="square"/>
+                    <a:lstStyle/>
+                    <a:p>
+                      <a:pPr algn="ctr"/>
+                      <a:r>
+                        <a:rPr sz="1600"/>
                         <a:t>0.26 / 35 s</a:t>
                       </a:r>
                     </a:p>
@@ -8488,6 +8729,20 @@
                       <a:pPr algn="ctr"/>
                       <a:r>
                         <a:rPr sz="1600"/>
+                        <a:t>11,191</a:t>
+                      </a:r>
+                    </a:p>
+                  </a:txBody>
+                  <a:tcPr anchor="ctr"/>
+                </a:tc>
+                <a:tc>
+                  <a:txBody>
+                    <a:bodyPr wrap="square"/>
+                    <a:lstStyle/>
+                    <a:p>
+                      <a:pPr algn="ctr"/>
+                      <a:r>
+                        <a:rPr sz="1600"/>
                         <a:t>0.20 / 30 s</a:t>
                       </a:r>
                     </a:p>
@@ -8574,6 +8829,20 @@
                       <a:pPr algn="ctr"/>
                       <a:r>
                         <a:rPr sz="1600"/>
+                        <a:t>17,936</a:t>
+                      </a:r>
+                    </a:p>
+                  </a:txBody>
+                  <a:tcPr anchor="ctr"/>
+                </a:tc>
+                <a:tc>
+                  <a:txBody>
+                    <a:bodyPr wrap="square"/>
+                    <a:lstStyle/>
+                    <a:p>
+                      <a:pPr algn="ctr"/>
+                      <a:r>
+                        <a:rPr sz="1600"/>
                         <a:t>0.18 / 40 s</a:t>
                       </a:r>
                     </a:p>
@@ -8647,6 +8916,20 @@
                       <a:r>
                         <a:rPr sz="1600"/>
                         <a:t>4,024</a:t>
+                      </a:r>
+                    </a:p>
+                  </a:txBody>
+                  <a:tcPr anchor="ctr"/>
+                </a:tc>
+                <a:tc>
+                  <a:txBody>
+                    <a:bodyPr wrap="square"/>
+                    <a:lstStyle/>
+                    <a:p>
+                      <a:pPr algn="ctr"/>
+                      <a:r>
+                        <a:rPr sz="1600"/>
+                        <a:t>30,205</a:t>
                       </a:r>
                     </a:p>
                   </a:txBody>

</xml_diff>

<commit_message>
Add a Ramírez & Geffner benchmarks results slide
Slide 12: max-term, SharpSAT-TD and d4 on IntrusionDetection (H = 6) and BlockWords (H = 15) with 1, 3, 5 observations, from CLARA/AAAI-2010-Benchmarks/results/runs.jsonl.  The archive slide lists the benchmarks; CLARA-preview.pdf re-rendered.

Co-Authored-By: Claude Opus 5.5 <noreply@anthropic.com>
</commit_message>
<xml_diff>
--- a/CLARA-slides.pptx
+++ b/CLARA-slides.pptx
@@ -17,6 +17,7 @@
     <p:sldId id="265" r:id="rId16"/>
     <p:sldId id="266" r:id="rId17"/>
     <p:sldId id="267" r:id="rId18"/>
+    <p:sldId id="268" r:id="rId19"/>
   </p:sldIdLst>
   <p:sldSz cx="12191695" cy="6858000" type="screen4x3"/>
   <p:notesSz cx="6858000" cy="9144000"/>
@@ -5030,6 +5031,897 @@
           <a:lstStyle/>
           <a:p>
             <a:r>
+              <a:t>Results on the Ramírez &amp; Geffner Benchmarks</a:t>
+            </a:r>
+          </a:p>
+        </p:txBody>
+      </p:sp>
+      <p:sp>
+        <p:nvSpPr>
+          <p:cNvPr id="3" name="Content Placeholder 2"/>
+          <p:cNvSpPr>
+            <a:spLocks noGrp="1"/>
+          </p:cNvSpPr>
+          <p:nvPr>
+            <p:ph idx="1"/>
+          </p:nvPr>
+        </p:nvSpPr>
+        <p:spPr/>
+        <p:txBody>
+          <a:bodyPr/>
+          <a:lstStyle/>
+          <a:p/>
+        </p:txBody>
+      </p:sp>
+      <p:sp>
+        <p:nvSpPr>
+          <p:cNvPr id="905" name="Body 5"/>
+          <p:cNvSpPr>
+            <a:spLocks noGrp="1"/>
+          </p:cNvSpPr>
+          <p:nvPr>
+            <p:ph idx="1"/>
+          </p:nvPr>
+        </p:nvSpPr>
+        <p:spPr>
+          <a:xfrm>
+            <a:off x="731520" y="5074920"/>
+            <a:ext cx="10698480" cy="1691640"/>
+          </a:xfrm>
+        </p:spPr>
+        <p:txBody>
+          <a:bodyPr wrap="square"/>
+          <a:lstStyle/>
+          <a:p>
+            <a:pPr>
+              <a:spcBef>
+                <a:spcPts val="600"/>
+              </a:spcBef>
+            </a:pPr>
+            <a:r>
+              <a:rPr sz="1600"/>
+              <a:t>P = probability given to the true goal, per-goal (Ramírez &amp; Geffner) baseline, uniform priors; 60-minute limit per run</a:t>
+            </a:r>
+          </a:p>
+          <a:p>
+            <a:pPr>
+              <a:spcBef>
+                <a:spcPts val="600"/>
+              </a:spcBef>
+            </a:pPr>
+            <a:r>
+              <a:rPr sz="1600"/>
+              <a:t>d4 compiled none, full or projected; at horizon 5 it compiles Intrusion in 55 s and matches SharpSAT-TD to 6 digits</a:t>
+            </a:r>
+          </a:p>
+          <a:p>
+            <a:pPr>
+              <a:spcBef>
+                <a:spcPts val="600"/>
+              </a:spcBef>
+            </a:pPr>
+            <a:r>
+              <a:rPr sz="1600"/>
+              <a:t>Intrusion: the exact posterior is nearly flat (0.09–0.12): over </a:t>
+            </a:r>
+            <a:r>
+              <a:rPr i="1" sz="1600"/>
+              <a:t>all</a:t>
+            </a:r>
+            <a:r>
+              <a:rPr sz="1600"/>
+              <a:t> plans the slack makes the observed recons likely under every goal; max-term sees only the cheapest plan</a:t>
+            </a:r>
+          </a:p>
+          <a:p>
+            <a:pPr>
+              <a:spcBef>
+                <a:spcPts val="600"/>
+              </a:spcBef>
+            </a:pPr>
+            <a:r>
+              <a:rPr sz="1600"/>
+              <a:t>BlockWords, 5 obs.: exact counting picks the true goal (0.64) where max-term ties it with a rival</a:t>
+            </a:r>
+          </a:p>
+        </p:txBody>
+      </p:sp>
+      <p:sp>
+        <p:nvSpPr>
+          <p:cNvPr id="4" name="TextBox 3"/>
+          <p:cNvSpPr txBox="1"/>
+          <p:nvPr/>
+        </p:nvSpPr>
+        <p:spPr>
+          <a:xfrm>
+            <a:off x="731520" y="1280160"/>
+            <a:ext cx="10698480" cy="822960"/>
+          </a:xfrm>
+          <a:prstGeom prst="rect">
+            <a:avLst/>
+          </a:prstGeom>
+          <a:noFill/>
+        </p:spPr>
+        <p:txBody>
+          <a:bodyPr wrap="square">
+            <a:spAutoFit/>
+          </a:bodyPr>
+          <a:lstStyle/>
+          <a:p>
+            <a:r>
+              <a:rPr sz="2000"/>
+              <a:t>Two AAAI-10 recognition problems, 1, 3 or 5 observed actions in order: IntrusionDetection (10 goals, horizon 6) and BlockWords (21 goals, horizon 15)</a:t>
+            </a:r>
+          </a:p>
+        </p:txBody>
+      </p:sp>
+      <p:graphicFrame>
+        <p:nvGraphicFramePr>
+          <p:cNvPr id="5" name="Table 4"/>
+          <p:cNvGraphicFramePr>
+            <a:graphicFrameLocks noGrp="1"/>
+          </p:cNvGraphicFramePr>
+          <p:nvPr/>
+        </p:nvGraphicFramePr>
+        <p:xfrm>
+          <a:off x="731520" y="1965960"/>
+          <a:ext cx="10515600" cy="2743200"/>
+        </p:xfrm>
+        <a:graphic>
+          <a:graphicData uri="http://schemas.openxmlformats.org/drawingml/2006/table">
+            <a:tbl>
+              <a:tblPr firstRow="1" bandRow="1">
+                <a:tableStyleId>{5C22544A-7EE6-4342-B048-85BDC9FD1C3A}</a:tableStyleId>
+              </a:tblPr>
+              <a:tblGrid>
+                <a:gridCol w="1463040"/>
+                <a:gridCol w="731520"/>
+                <a:gridCol w="1097280"/>
+                <a:gridCol w="1325880"/>
+                <a:gridCol w="2194560"/>
+                <a:gridCol w="2194560"/>
+                <a:gridCol w="1508760"/>
+              </a:tblGrid>
+              <a:tr h="391885">
+                <a:tc>
+                  <a:txBody>
+                    <a:bodyPr wrap="square"/>
+                    <a:lstStyle/>
+                    <a:p>
+                      <a:pPr algn="l"/>
+                      <a:r>
+                        <a:rPr sz="1600"/>
+                        <a:t>Problem</a:t>
+                      </a:r>
+                    </a:p>
+                  </a:txBody>
+                  <a:tcPr anchor="ctr"/>
+                </a:tc>
+                <a:tc>
+                  <a:txBody>
+                    <a:bodyPr wrap="square"/>
+                    <a:lstStyle/>
+                    <a:p>
+                      <a:pPr algn="ctr"/>
+                      <a:r>
+                        <a:rPr sz="1600"/>
+                        <a:t>Obs.</a:t>
+                      </a:r>
+                    </a:p>
+                  </a:txBody>
+                  <a:tcPr anchor="ctr"/>
+                </a:tc>
+                <a:tc>
+                  <a:txBody>
+                    <a:bodyPr wrap="square"/>
+                    <a:lstStyle/>
+                    <a:p>
+                      <a:pPr algn="ctr"/>
+                      <a:r>
+                        <a:rPr sz="1600"/>
+                        <a:t>CNF vars</a:t>
+                      </a:r>
+                    </a:p>
+                  </a:txBody>
+                  <a:tcPr anchor="ctr"/>
+                </a:tc>
+                <a:tc>
+                  <a:txBody>
+                    <a:bodyPr wrap="square"/>
+                    <a:lstStyle/>
+                    <a:p>
+                      <a:pPr algn="ctr"/>
+                      <a:r>
+                        <a:rPr sz="1600"/>
+                        <a:t>CNF clauses</a:t>
+                      </a:r>
+                    </a:p>
+                  </a:txBody>
+                  <a:tcPr anchor="ctr"/>
+                </a:tc>
+                <a:tc>
+                  <a:txBody>
+                    <a:bodyPr wrap="square"/>
+                    <a:lstStyle/>
+                    <a:p>
+                      <a:pPr algn="ctr"/>
+                      <a:r>
+                        <a:rPr sz="1600"/>
+                        <a:t>Max-term
+P, rank / time</a:t>
+                      </a:r>
+                    </a:p>
+                  </a:txBody>
+                  <a:tcPr anchor="ctr"/>
+                </a:tc>
+                <a:tc>
+                  <a:txBody>
+                    <a:bodyPr wrap="square"/>
+                    <a:lstStyle/>
+                    <a:p>
+                      <a:pPr algn="ctr"/>
+                      <a:r>
+                        <a:rPr sz="1600"/>
+                        <a:t>SharpSAT-TD
+P, rank / time</a:t>
+                      </a:r>
+                    </a:p>
+                  </a:txBody>
+                  <a:tcPr anchor="ctr"/>
+                </a:tc>
+                <a:tc>
+                  <a:txBody>
+                    <a:bodyPr wrap="square"/>
+                    <a:lstStyle/>
+                    <a:p>
+                      <a:pPr algn="ctr"/>
+                      <a:r>
+                        <a:rPr sz="1600"/>
+                        <a:t>d4 compile</a:t>
+                      </a:r>
+                    </a:p>
+                  </a:txBody>
+                  <a:tcPr anchor="ctr"/>
+                </a:tc>
+              </a:tr>
+              <a:tr h="391885">
+                <a:tc>
+                  <a:txBody>
+                    <a:bodyPr wrap="square"/>
+                    <a:lstStyle/>
+                    <a:p>
+                      <a:pPr algn="l"/>
+                      <a:r>
+                        <a:rPr sz="1600"/>
+                        <a:t>Intrusion</a:t>
+                      </a:r>
+                    </a:p>
+                  </a:txBody>
+                  <a:tcPr anchor="ctr"/>
+                </a:tc>
+                <a:tc>
+                  <a:txBody>
+                    <a:bodyPr wrap="square"/>
+                    <a:lstStyle/>
+                    <a:p>
+                      <a:pPr algn="ctr"/>
+                      <a:r>
+                        <a:rPr sz="1600"/>
+                        <a:t>1</a:t>
+                      </a:r>
+                    </a:p>
+                  </a:txBody>
+                  <a:tcPr anchor="ctr"/>
+                </a:tc>
+                <a:tc>
+                  <a:txBody>
+                    <a:bodyPr wrap="square"/>
+                    <a:lstStyle/>
+                    <a:p>
+                      <a:pPr algn="ctr"/>
+                      <a:r>
+                        <a:rPr sz="1600"/>
+                        <a:t>1,056</a:t>
+                      </a:r>
+                    </a:p>
+                  </a:txBody>
+                  <a:tcPr anchor="ctr"/>
+                </a:tc>
+                <a:tc>
+                  <a:txBody>
+                    <a:bodyPr wrap="square"/>
+                    <a:lstStyle/>
+                    <a:p>
+                      <a:pPr algn="ctr"/>
+                      <a:r>
+                        <a:rPr sz="1600"/>
+                        <a:t>2,239</a:t>
+                      </a:r>
+                    </a:p>
+                  </a:txBody>
+                  <a:tcPr anchor="ctr"/>
+                </a:tc>
+                <a:tc>
+                  <a:txBody>
+                    <a:bodyPr wrap="square"/>
+                    <a:lstStyle/>
+                    <a:p>
+                      <a:pPr algn="ctr"/>
+                      <a:r>
+                        <a:rPr sz="1600"/>
+                        <a:t>0.16, tied 1st / 8 s</a:t>
+                      </a:r>
+                    </a:p>
+                  </a:txBody>
+                  <a:tcPr anchor="ctr"/>
+                </a:tc>
+                <a:tc>
+                  <a:txBody>
+                    <a:bodyPr wrap="square"/>
+                    <a:lstStyle/>
+                    <a:p>
+                      <a:pPr algn="ctr"/>
+                      <a:r>
+                        <a:rPr sz="1600"/>
+                        <a:t>0.10, tied 1st / 42 s</a:t>
+                      </a:r>
+                    </a:p>
+                  </a:txBody>
+                  <a:tcPr anchor="ctr"/>
+                </a:tc>
+                <a:tc>
+                  <a:txBody>
+                    <a:bodyPr wrap="square"/>
+                    <a:lstStyle/>
+                    <a:p>
+                      <a:pPr algn="ctr"/>
+                      <a:r>
+                        <a:rPr sz="1600"/>
+                        <a:t>timeout</a:t>
+                      </a:r>
+                    </a:p>
+                  </a:txBody>
+                  <a:tcPr anchor="ctr"/>
+                </a:tc>
+              </a:tr>
+              <a:tr h="391885">
+                <a:tc>
+                  <a:txBody>
+                    <a:bodyPr wrap="square"/>
+                    <a:lstStyle/>
+                    <a:p>
+                      <a:pPr algn="l"/>
+                      <a:r>
+                        <a:rPr sz="1600"/>
+                        <a:t>Intrusion</a:t>
+                      </a:r>
+                    </a:p>
+                  </a:txBody>
+                  <a:tcPr anchor="ctr"/>
+                </a:tc>
+                <a:tc>
+                  <a:txBody>
+                    <a:bodyPr wrap="square"/>
+                    <a:lstStyle/>
+                    <a:p>
+                      <a:pPr algn="ctr"/>
+                      <a:r>
+                        <a:rPr sz="1600"/>
+                        <a:t>3</a:t>
+                      </a:r>
+                    </a:p>
+                  </a:txBody>
+                  <a:tcPr anchor="ctr"/>
+                </a:tc>
+                <a:tc>
+                  <a:txBody>
+                    <a:bodyPr wrap="square"/>
+                    <a:lstStyle/>
+                    <a:p>
+                      <a:pPr algn="ctr"/>
+                      <a:r>
+                        <a:rPr sz="1600"/>
+                        <a:t>1,068</a:t>
+                      </a:r>
+                    </a:p>
+                  </a:txBody>
+                  <a:tcPr anchor="ctr"/>
+                </a:tc>
+                <a:tc>
+                  <a:txBody>
+                    <a:bodyPr wrap="square"/>
+                    <a:lstStyle/>
+                    <a:p>
+                      <a:pPr algn="ctr"/>
+                      <a:r>
+                        <a:rPr sz="1600"/>
+                        <a:t>2,281</a:t>
+                      </a:r>
+                    </a:p>
+                  </a:txBody>
+                  <a:tcPr anchor="ctr"/>
+                </a:tc>
+                <a:tc>
+                  <a:txBody>
+                    <a:bodyPr wrap="square"/>
+                    <a:lstStyle/>
+                    <a:p>
+                      <a:pPr algn="ctr"/>
+                      <a:r>
+                        <a:rPr sz="1600"/>
+                        <a:t>0.37, 1st / 10 s</a:t>
+                      </a:r>
+                    </a:p>
+                  </a:txBody>
+                  <a:tcPr anchor="ctr"/>
+                </a:tc>
+                <a:tc>
+                  <a:txBody>
+                    <a:bodyPr wrap="square"/>
+                    <a:lstStyle/>
+                    <a:p>
+                      <a:pPr algn="ctr"/>
+                      <a:r>
+                        <a:rPr sz="1600"/>
+                        <a:t>0.10, 3rd / 99 s</a:t>
+                      </a:r>
+                    </a:p>
+                  </a:txBody>
+                  <a:tcPr anchor="ctr"/>
+                </a:tc>
+                <a:tc>
+                  <a:txBody>
+                    <a:bodyPr wrap="square"/>
+                    <a:lstStyle/>
+                    <a:p>
+                      <a:pPr algn="ctr"/>
+                      <a:r>
+                        <a:rPr sz="1600"/>
+                        <a:t>timeout</a:t>
+                      </a:r>
+                    </a:p>
+                  </a:txBody>
+                  <a:tcPr anchor="ctr"/>
+                </a:tc>
+              </a:tr>
+              <a:tr h="391885">
+                <a:tc>
+                  <a:txBody>
+                    <a:bodyPr wrap="square"/>
+                    <a:lstStyle/>
+                    <a:p>
+                      <a:pPr algn="l"/>
+                      <a:r>
+                        <a:rPr sz="1600"/>
+                        <a:t>Intrusion</a:t>
+                      </a:r>
+                    </a:p>
+                  </a:txBody>
+                  <a:tcPr anchor="ctr"/>
+                </a:tc>
+                <a:tc>
+                  <a:txBody>
+                    <a:bodyPr wrap="square"/>
+                    <a:lstStyle/>
+                    <a:p>
+                      <a:pPr algn="ctr"/>
+                      <a:r>
+                        <a:rPr sz="1600"/>
+                        <a:t>5</a:t>
+                      </a:r>
+                    </a:p>
+                  </a:txBody>
+                  <a:tcPr anchor="ctr"/>
+                </a:tc>
+                <a:tc>
+                  <a:txBody>
+                    <a:bodyPr wrap="square"/>
+                    <a:lstStyle/>
+                    <a:p>
+                      <a:pPr algn="ctr"/>
+                      <a:r>
+                        <a:rPr sz="1600"/>
+                        <a:t>1,080</a:t>
+                      </a:r>
+                    </a:p>
+                  </a:txBody>
+                  <a:tcPr anchor="ctr"/>
+                </a:tc>
+                <a:tc>
+                  <a:txBody>
+                    <a:bodyPr wrap="square"/>
+                    <a:lstStyle/>
+                    <a:p>
+                      <a:pPr algn="ctr"/>
+                      <a:r>
+                        <a:rPr sz="1600"/>
+                        <a:t>2,323</a:t>
+                      </a:r>
+                    </a:p>
+                  </a:txBody>
+                  <a:tcPr anchor="ctr"/>
+                </a:tc>
+                <a:tc>
+                  <a:txBody>
+                    <a:bodyPr wrap="square"/>
+                    <a:lstStyle/>
+                    <a:p>
+                      <a:pPr algn="ctr"/>
+                      <a:r>
+                        <a:rPr sz="1600"/>
+                        <a:t>0.67, 1st / 10 s</a:t>
+                      </a:r>
+                    </a:p>
+                  </a:txBody>
+                  <a:tcPr anchor="ctr"/>
+                </a:tc>
+                <a:tc>
+                  <a:txBody>
+                    <a:bodyPr wrap="square"/>
+                    <a:lstStyle/>
+                    <a:p>
+                      <a:pPr algn="ctr"/>
+                      <a:r>
+                        <a:rPr sz="1600"/>
+                        <a:t>0.10, 3rd / 49 s</a:t>
+                      </a:r>
+                    </a:p>
+                  </a:txBody>
+                  <a:tcPr anchor="ctr"/>
+                </a:tc>
+                <a:tc>
+                  <a:txBody>
+                    <a:bodyPr wrap="square"/>
+                    <a:lstStyle/>
+                    <a:p>
+                      <a:pPr algn="ctr"/>
+                      <a:r>
+                        <a:rPr sz="1600"/>
+                        <a:t>timeout</a:t>
+                      </a:r>
+                    </a:p>
+                  </a:txBody>
+                  <a:tcPr anchor="ctr"/>
+                </a:tc>
+              </a:tr>
+              <a:tr h="391885">
+                <a:tc>
+                  <a:txBody>
+                    <a:bodyPr wrap="square"/>
+                    <a:lstStyle/>
+                    <a:p>
+                      <a:pPr algn="l"/>
+                      <a:r>
+                        <a:rPr sz="1600"/>
+                        <a:t>BlockWords</a:t>
+                      </a:r>
+                    </a:p>
+                  </a:txBody>
+                  <a:tcPr anchor="ctr"/>
+                </a:tc>
+                <a:tc>
+                  <a:txBody>
+                    <a:bodyPr wrap="square"/>
+                    <a:lstStyle/>
+                    <a:p>
+                      <a:pPr algn="ctr"/>
+                      <a:r>
+                        <a:rPr sz="1600"/>
+                        <a:t>1</a:t>
+                      </a:r>
+                    </a:p>
+                  </a:txBody>
+                  <a:tcPr anchor="ctr"/>
+                </a:tc>
+                <a:tc>
+                  <a:txBody>
+                    <a:bodyPr wrap="square"/>
+                    <a:lstStyle/>
+                    <a:p>
+                      <a:pPr algn="ctr"/>
+                      <a:r>
+                        <a:rPr sz="1600"/>
+                        <a:t>3,681</a:t>
+                      </a:r>
+                    </a:p>
+                  </a:txBody>
+                  <a:tcPr anchor="ctr"/>
+                </a:tc>
+                <a:tc>
+                  <a:txBody>
+                    <a:bodyPr wrap="square"/>
+                    <a:lstStyle/>
+                    <a:p>
+                      <a:pPr algn="ctr"/>
+                      <a:r>
+                        <a:rPr sz="1600"/>
+                        <a:t>240,551</a:t>
+                      </a:r>
+                    </a:p>
+                  </a:txBody>
+                  <a:tcPr anchor="ctr"/>
+                </a:tc>
+                <a:tc>
+                  <a:txBody>
+                    <a:bodyPr wrap="square"/>
+                    <a:lstStyle/>
+                    <a:p>
+                      <a:pPr algn="ctr"/>
+                      <a:r>
+                        <a:rPr sz="1600"/>
+                        <a:t>0.05, tied 1st / 49 s</a:t>
+                      </a:r>
+                    </a:p>
+                  </a:txBody>
+                  <a:tcPr anchor="ctr"/>
+                </a:tc>
+                <a:tc>
+                  <a:txBody>
+                    <a:bodyPr wrap="square"/>
+                    <a:lstStyle/>
+                    <a:p>
+                      <a:pPr algn="ctr"/>
+                      <a:r>
+                        <a:rPr sz="1600"/>
+                        <a:t>timeout</a:t>
+                      </a:r>
+                    </a:p>
+                  </a:txBody>
+                  <a:tcPr anchor="ctr"/>
+                </a:tc>
+                <a:tc>
+                  <a:txBody>
+                    <a:bodyPr wrap="square"/>
+                    <a:lstStyle/>
+                    <a:p>
+                      <a:pPr algn="ctr"/>
+                      <a:r>
+                        <a:rPr sz="1600"/>
+                        <a:t>timeout</a:t>
+                      </a:r>
+                    </a:p>
+                  </a:txBody>
+                  <a:tcPr anchor="ctr"/>
+                </a:tc>
+              </a:tr>
+              <a:tr h="391885">
+                <a:tc>
+                  <a:txBody>
+                    <a:bodyPr wrap="square"/>
+                    <a:lstStyle/>
+                    <a:p>
+                      <a:pPr algn="l"/>
+                      <a:r>
+                        <a:rPr sz="1600"/>
+                        <a:t>BlockWords</a:t>
+                      </a:r>
+                    </a:p>
+                  </a:txBody>
+                  <a:tcPr anchor="ctr"/>
+                </a:tc>
+                <a:tc>
+                  <a:txBody>
+                    <a:bodyPr wrap="square"/>
+                    <a:lstStyle/>
+                    <a:p>
+                      <a:pPr algn="ctr"/>
+                      <a:r>
+                        <a:rPr sz="1600"/>
+                        <a:t>3</a:t>
+                      </a:r>
+                    </a:p>
+                  </a:txBody>
+                  <a:tcPr anchor="ctr"/>
+                </a:tc>
+                <a:tc>
+                  <a:txBody>
+                    <a:bodyPr wrap="square"/>
+                    <a:lstStyle/>
+                    <a:p>
+                      <a:pPr algn="ctr"/>
+                      <a:r>
+                        <a:rPr sz="1600"/>
+                        <a:t>3,711</a:t>
+                      </a:r>
+                    </a:p>
+                  </a:txBody>
+                  <a:tcPr anchor="ctr"/>
+                </a:tc>
+                <a:tc>
+                  <a:txBody>
+                    <a:bodyPr wrap="square"/>
+                    <a:lstStyle/>
+                    <a:p>
+                      <a:pPr algn="ctr"/>
+                      <a:r>
+                        <a:rPr sz="1600"/>
+                        <a:t>240,665</a:t>
+                      </a:r>
+                    </a:p>
+                  </a:txBody>
+                  <a:tcPr anchor="ctr"/>
+                </a:tc>
+                <a:tc>
+                  <a:txBody>
+                    <a:bodyPr wrap="square"/>
+                    <a:lstStyle/>
+                    <a:p>
+                      <a:pPr algn="ctr"/>
+                      <a:r>
+                        <a:rPr sz="1600"/>
+                        <a:t>0.12, 2nd / 61 s</a:t>
+                      </a:r>
+                    </a:p>
+                  </a:txBody>
+                  <a:tcPr anchor="ctr"/>
+                </a:tc>
+                <a:tc>
+                  <a:txBody>
+                    <a:bodyPr wrap="square"/>
+                    <a:lstStyle/>
+                    <a:p>
+                      <a:pPr algn="ctr"/>
+                      <a:r>
+                        <a:rPr sz="1600"/>
+                        <a:t>timeout</a:t>
+                      </a:r>
+                    </a:p>
+                  </a:txBody>
+                  <a:tcPr anchor="ctr"/>
+                </a:tc>
+                <a:tc>
+                  <a:txBody>
+                    <a:bodyPr wrap="square"/>
+                    <a:lstStyle/>
+                    <a:p>
+                      <a:pPr algn="ctr"/>
+                      <a:r>
+                        <a:rPr sz="1600"/>
+                        <a:t>timeout</a:t>
+                      </a:r>
+                    </a:p>
+                  </a:txBody>
+                  <a:tcPr anchor="ctr"/>
+                </a:tc>
+              </a:tr>
+              <a:tr h="391890">
+                <a:tc>
+                  <a:txBody>
+                    <a:bodyPr wrap="square"/>
+                    <a:lstStyle/>
+                    <a:p>
+                      <a:pPr algn="l"/>
+                      <a:r>
+                        <a:rPr sz="1600"/>
+                        <a:t>BlockWords</a:t>
+                      </a:r>
+                    </a:p>
+                  </a:txBody>
+                  <a:tcPr anchor="ctr"/>
+                </a:tc>
+                <a:tc>
+                  <a:txBody>
+                    <a:bodyPr wrap="square"/>
+                    <a:lstStyle/>
+                    <a:p>
+                      <a:pPr algn="ctr"/>
+                      <a:r>
+                        <a:rPr sz="1600"/>
+                        <a:t>5</a:t>
+                      </a:r>
+                    </a:p>
+                  </a:txBody>
+                  <a:tcPr anchor="ctr"/>
+                </a:tc>
+                <a:tc>
+                  <a:txBody>
+                    <a:bodyPr wrap="square"/>
+                    <a:lstStyle/>
+                    <a:p>
+                      <a:pPr algn="ctr"/>
+                      <a:r>
+                        <a:rPr sz="1600"/>
+                        <a:t>3,741</a:t>
+                      </a:r>
+                    </a:p>
+                  </a:txBody>
+                  <a:tcPr anchor="ctr"/>
+                </a:tc>
+                <a:tc>
+                  <a:txBody>
+                    <a:bodyPr wrap="square"/>
+                    <a:lstStyle/>
+                    <a:p>
+                      <a:pPr algn="ctr"/>
+                      <a:r>
+                        <a:rPr sz="1600"/>
+                        <a:t>240,779</a:t>
+                      </a:r>
+                    </a:p>
+                  </a:txBody>
+                  <a:tcPr anchor="ctr"/>
+                </a:tc>
+                <a:tc>
+                  <a:txBody>
+                    <a:bodyPr wrap="square"/>
+                    <a:lstStyle/>
+                    <a:p>
+                      <a:pPr algn="ctr"/>
+                      <a:r>
+                        <a:rPr sz="1600"/>
+                        <a:t>0.31, tied 1st / 60 s</a:t>
+                      </a:r>
+                    </a:p>
+                  </a:txBody>
+                  <a:tcPr anchor="ctr"/>
+                </a:tc>
+                <a:tc>
+                  <a:txBody>
+                    <a:bodyPr wrap="square"/>
+                    <a:lstStyle/>
+                    <a:p>
+                      <a:pPr algn="ctr"/>
+                      <a:r>
+                        <a:rPr sz="1600"/>
+                        <a:t>0.64, 1st / 57 min</a:t>
+                      </a:r>
+                    </a:p>
+                  </a:txBody>
+                  <a:tcPr anchor="ctr"/>
+                </a:tc>
+                <a:tc>
+                  <a:txBody>
+                    <a:bodyPr wrap="square"/>
+                    <a:lstStyle/>
+                    <a:p>
+                      <a:pPr algn="ctr"/>
+                      <a:r>
+                        <a:rPr sz="1600"/>
+                        <a:t>timeout</a:t>
+                      </a:r>
+                    </a:p>
+                  </a:txBody>
+                  <a:tcPr anchor="ctr"/>
+                </a:tc>
+              </a:tr>
+            </a:tbl>
+          </a:graphicData>
+        </a:graphic>
+      </p:graphicFrame>
+    </p:spTree>
+  </p:cSld>
+  <p:clrMapOvr>
+    <a:masterClrMapping/>
+  </p:clrMapOvr>
+</p:sld>
+</file>
+
+<file path=ppt/slides/slide13.xml><?xml version="1.0" encoding="utf-8"?>
+<p:sld xmlns:a="http://schemas.openxmlformats.org/drawingml/2006/main" xmlns:p="http://schemas.openxmlformats.org/presentationml/2006/main" xmlns:r="http://schemas.openxmlformats.org/officeDocument/2006/relationships">
+  <p:cSld>
+    <p:spTree>
+      <p:nvGrpSpPr>
+        <p:cNvPr id="1" name=""/>
+        <p:cNvGrpSpPr/>
+        <p:nvPr/>
+      </p:nvGrpSpPr>
+      <p:grpSpPr/>
+      <p:sp>
+        <p:nvSpPr>
+          <p:cNvPr id="2" name="Title 1"/>
+          <p:cNvSpPr>
+            <a:spLocks noGrp="1"/>
+          </p:cNvSpPr>
+          <p:nvPr>
+            <p:ph type="title"/>
+          </p:nvPr>
+        </p:nvSpPr>
+        <p:spPr/>
+        <p:txBody>
+          <a:bodyPr/>
+          <a:lstStyle/>
+          <a:p>
+            <a:r>
               <a:t>Test Problem Archive</a:t>
             </a:r>
           </a:p>
@@ -5133,11 +6025,26 @@
             </a:pPr>
             <a:r>
               <a:rPr b="1" sz="2800"/>
+              <a:t>Ramírez &amp; Geffner benchmarks:</a:t>
+            </a:r>
+            <a:r>
+              <a:rPr sz="2800"/>
+              <a:t> BlockWords and IntrusionDetection (AAAI-10), with theories, weighted CNFs and results</a:t>
+            </a:r>
+          </a:p>
+          <a:p>
+            <a:pPr>
+              <a:spcBef>
+                <a:spcPts val="600"/>
+              </a:spcBef>
+            </a:pPr>
+            <a:r>
+              <a:rPr b="1" sz="2800"/>
               <a:t>Baseline results:</a:t>
             </a:r>
             <a:r>
               <a:rPr sz="2800"/>
-              <a:t> the tables on the previous three slides</a:t>
+              <a:t> the tables on the previous four slides</a:t>
             </a:r>
           </a:p>
         </p:txBody>

</xml_diff>